<commit_message>
docs: correct title-slide department to Economics
</commit_message>
<xml_diff>
--- a/PRESENTATION.pptx
+++ b/PRESENTATION.pptx
@@ -4457,6 +4457,10 @@
             <a:prstDash val="solid"/>
           </a:ln>
         </p:spPr>
+        <p:txBody>
+          <a:bodyPr/>
+          <a:p/>
+        </p:txBody>
       </p:sp>
       <p:sp>
         <p:nvSpPr>
@@ -4638,6 +4642,10 @@
             <a:prstDash val="solid"/>
           </a:ln>
         </p:spPr>
+        <p:txBody>
+          <a:bodyPr/>
+          <a:p/>
+        </p:txBody>
       </p:sp>
       <p:sp>
         <p:nvSpPr>
@@ -4695,7 +4703,7 @@
                 <a:ea typeface="Calibri" pitchFamily="34" charset="-122"/>
                 <a:cs typeface="Calibri" pitchFamily="34" charset="-120"/>
               </a:rPr>
-              <a:t>International Relations  ·  Final Project Presentation</a:t>
+              <a:t>Department of Economics  ·  Final Project Presentation</a:t>
             </a:r>
             <a:endParaRPr lang="en-US" sz="1800" dirty="0"/>
           </a:p>

</xml_diff>